<commit_message>
Final push prior to sumbission: - Finalized readme (added demo link) - Minor html changes.
</commit_message>
<xml_diff>
--- a/SPyC Overview.pptx
+++ b/SPyC Overview.pptx
@@ -5,12 +5,13 @@
     <p:sldMasterId id="2147483648" r:id="rId1"/>
   </p:sldMasterIdLst>
   <p:notesMasterIdLst>
-    <p:notesMasterId r:id="rId7"/>
+    <p:notesMasterId r:id="rId8"/>
   </p:notesMasterIdLst>
   <p:sldIdLst>
     <p:sldId id="256" r:id="rId4"/>
     <p:sldId id="257" r:id="rId5"/>
     <p:sldId id="258" r:id="rId6"/>
+    <p:sldId id="259" r:id="rId7"/>
   </p:sldIdLst>
   <p:sldSz cx="12192000" cy="6858000"/>
   <p:notesSz cx="6858000" cy="9144000"/>
@@ -136,7 +137,7 @@
       </p:grpSpPr>
       <p:sp>
         <p:nvSpPr>
-          <p:cNvPr id="1179986661" name="Header Placeholder 1"/>
+          <p:cNvPr id="21146231" name="Header Placeholder 1"/>
           <p:cNvSpPr>
             <a:spLocks noGrp="1"/>
           </p:cNvSpPr>
@@ -170,7 +171,7 @@
       </p:sp>
       <p:sp>
         <p:nvSpPr>
-          <p:cNvPr id="1923648519" name="Date Placeholder 2"/>
+          <p:cNvPr id="1358641346" name="Date Placeholder 2"/>
           <p:cNvSpPr>
             <a:spLocks noGrp="1"/>
           </p:cNvSpPr>
@@ -208,7 +209,7 @@
       </p:sp>
       <p:sp>
         <p:nvSpPr>
-          <p:cNvPr id="1739670658" name="Slide Image Placeholder 3"/>
+          <p:cNvPr id="1114836186" name="Slide Image Placeholder 3"/>
           <p:cNvSpPr>
             <a:spLocks noChangeAspect="1" noGrp="1" noRot="1"/>
           </p:cNvSpPr>
@@ -244,7 +245,7 @@
       </p:sp>
       <p:sp>
         <p:nvSpPr>
-          <p:cNvPr id="1438133218" name="Notes Placeholder 4"/>
+          <p:cNvPr id="158397425" name="Notes Placeholder 4"/>
           <p:cNvSpPr>
             <a:spLocks noGrp="1"/>
           </p:cNvSpPr>
@@ -318,7 +319,7 @@
       </p:sp>
       <p:sp>
         <p:nvSpPr>
-          <p:cNvPr id="1026226640" name="Footer Placeholder 5"/>
+          <p:cNvPr id="1397865884" name="Footer Placeholder 5"/>
           <p:cNvSpPr>
             <a:spLocks noGrp="1"/>
           </p:cNvSpPr>
@@ -352,7 +353,7 @@
       </p:sp>
       <p:sp>
         <p:nvSpPr>
-          <p:cNvPr id="716585703" name="Slide Number Placeholder 6"/>
+          <p:cNvPr id="1302075472" name="Slide Number Placeholder 6"/>
           <p:cNvSpPr>
             <a:spLocks noGrp="1"/>
           </p:cNvSpPr>
@@ -505,7 +506,7 @@
       </p:grpSpPr>
       <p:sp>
         <p:nvSpPr>
-          <p:cNvPr id="1953244307" name="Slide Image Placeholder 1"/>
+          <p:cNvPr id="101071392" name="Slide Image Placeholder 1"/>
           <p:cNvSpPr>
             <a:spLocks noChangeAspect="1" noGrp="1" noRot="1"/>
           </p:cNvSpPr>
@@ -522,7 +523,7 @@
       </p:sp>
       <p:sp>
         <p:nvSpPr>
-          <p:cNvPr id="1119216376" name="Notes Placeholder 2"/>
+          <p:cNvPr id="1303503031" name="Notes Placeholder 2"/>
           <p:cNvSpPr>
             <a:spLocks noGrp="1"/>
           </p:cNvSpPr>
@@ -547,7 +548,7 @@
       </p:sp>
       <p:sp>
         <p:nvSpPr>
-          <p:cNvPr id="442083832" name="Slide Number Placeholder 3"/>
+          <p:cNvPr id="959136813" name="Slide Number Placeholder 3"/>
           <p:cNvSpPr>
             <a:spLocks noGrp="1"/>
           </p:cNvSpPr>
@@ -598,7 +599,7 @@
       </p:grpSpPr>
       <p:sp>
         <p:nvSpPr>
-          <p:cNvPr id="2" name="Slide Image Placeholder 1"/>
+          <p:cNvPr id="311568351" name="Slide Image Placeholder 1"/>
           <p:cNvSpPr>
             <a:spLocks noChangeAspect="1" noGrp="1" noRot="1"/>
           </p:cNvSpPr>
@@ -610,7 +611,7 @@
       </p:sp>
       <p:sp>
         <p:nvSpPr>
-          <p:cNvPr id="3" name="Notes Placeholder 2"/>
+          <p:cNvPr id="494264817" name="Notes Placeholder 2"/>
           <p:cNvSpPr>
             <a:spLocks noGrp="1"/>
           </p:cNvSpPr>
@@ -632,7 +633,7 @@
       </p:sp>
       <p:sp>
         <p:nvSpPr>
-          <p:cNvPr id="4" name="Slide Number Placeholder 3"/>
+          <p:cNvPr id="913985966" name="Slide Number Placeholder 3"/>
           <p:cNvSpPr>
             <a:spLocks noGrp="1"/>
           </p:cNvSpPr>
@@ -733,6 +734,91 @@
             <a:pPr>
               <a:defRPr/>
             </a:pPr>
+            <a:fld id="{71DAE6DA-5FAF-8029-6FB7-00264FC110A3}" type="slidenum">
+              <a:rPr/>
+              <a:t/>
+            </a:fld>
+            <a:endParaRPr/>
+          </a:p>
+        </p:txBody>
+      </p:sp>
+    </p:spTree>
+  </p:cSld>
+  <p:clrMapOvr>
+    <a:masterClrMapping/>
+  </p:clrMapOvr>
+</p:notes>
+</file>
+
+<file path=ppt/notesSlides/notesSlide4.xml><?xml version="1.0" encoding="utf-8"?>
+<p:notes xmlns:a="http://schemas.openxmlformats.org/drawingml/2006/main" xmlns:r="http://schemas.openxmlformats.org/officeDocument/2006/relationships" xmlns:p="http://schemas.openxmlformats.org/presentationml/2006/main" xmlns:m="http://schemas.openxmlformats.org/officeDocument/2006/math" xmlns:w="http://schemas.openxmlformats.org/wordprocessingml/2006/main">
+  <p:cSld name="">
+    <p:spTree>
+      <p:nvGrpSpPr>
+        <p:cNvPr id="1" name=""/>
+        <p:cNvGrpSpPr/>
+        <p:nvPr/>
+      </p:nvGrpSpPr>
+      <p:grpSpPr bwMode="auto">
+        <a:xfrm>
+          <a:off x="0" y="0"/>
+          <a:ext cx="0" cy="0"/>
+          <a:chOff x="0" y="0"/>
+          <a:chExt cx="0" cy="0"/>
+        </a:xfrm>
+      </p:grpSpPr>
+      <p:sp>
+        <p:nvSpPr>
+          <p:cNvPr id="513553330" name="Slide Image Placeholder 1"/>
+          <p:cNvSpPr>
+            <a:spLocks noChangeAspect="1" noGrp="1" noRot="1"/>
+          </p:cNvSpPr>
+          <p:nvPr>
+            <p:ph type="sldImg"/>
+          </p:nvPr>
+        </p:nvSpPr>
+        <p:spPr bwMode="auto"/>
+      </p:sp>
+      <p:sp>
+        <p:nvSpPr>
+          <p:cNvPr id="1756126516" name="Notes Placeholder 2"/>
+          <p:cNvSpPr>
+            <a:spLocks noGrp="1"/>
+          </p:cNvSpPr>
+          <p:nvPr>
+            <p:ph type="body" idx="1"/>
+          </p:nvPr>
+        </p:nvSpPr>
+        <p:spPr bwMode="auto"/>
+        <p:txBody>
+          <a:bodyPr/>
+          <a:lstStyle/>
+          <a:p>
+            <a:pPr>
+              <a:defRPr/>
+            </a:pPr>
+            <a:endParaRPr/>
+          </a:p>
+        </p:txBody>
+      </p:sp>
+      <p:sp>
+        <p:nvSpPr>
+          <p:cNvPr id="1333754262" name="Slide Number Placeholder 3"/>
+          <p:cNvSpPr>
+            <a:spLocks noGrp="1"/>
+          </p:cNvSpPr>
+          <p:nvPr>
+            <p:ph type="sldNum" sz="quarter" idx="10"/>
+          </p:nvPr>
+        </p:nvSpPr>
+        <p:spPr bwMode="auto"/>
+        <p:txBody>
+          <a:bodyPr/>
+          <a:lstStyle/>
+          <a:p>
+            <a:pPr>
+              <a:defRPr/>
+            </a:pPr>
             <a:fld id="{845BDB5D-F22F-1E80-70C9-4C0EB748FD01}" type="slidenum">
               <a:rPr/>
               <a:t/>
@@ -768,7 +854,7 @@
       </p:grpSpPr>
       <p:sp>
         <p:nvSpPr>
-          <p:cNvPr id="1069078216" name="Title 1"/>
+          <p:cNvPr id="234557355" name="Title 1"/>
           <p:cNvSpPr>
             <a:spLocks noGrp="1"/>
           </p:cNvSpPr>
@@ -803,7 +889,7 @@
       </p:sp>
       <p:sp>
         <p:nvSpPr>
-          <p:cNvPr id="146638579" name="Subtitle 2"/>
+          <p:cNvPr id="420197544" name="Subtitle 2"/>
           <p:cNvSpPr>
             <a:spLocks noGrp="1"/>
           </p:cNvSpPr>
@@ -871,7 +957,7 @@
       </p:sp>
       <p:sp>
         <p:nvSpPr>
-          <p:cNvPr id="1949952962" name="Date Placeholder 3"/>
+          <p:cNvPr id="226873803" name="Date Placeholder 3"/>
           <p:cNvSpPr>
             <a:spLocks noGrp="1"/>
           </p:cNvSpPr>
@@ -897,7 +983,7 @@
       </p:sp>
       <p:sp>
         <p:nvSpPr>
-          <p:cNvPr id="1704804914" name="Footer Placeholder 4"/>
+          <p:cNvPr id="1889048313" name="Footer Placeholder 4"/>
           <p:cNvSpPr>
             <a:spLocks noGrp="1"/>
           </p:cNvSpPr>
@@ -919,7 +1005,7 @@
       </p:sp>
       <p:sp>
         <p:nvSpPr>
-          <p:cNvPr id="1496125392" name="Slide Number Placeholder 5"/>
+          <p:cNvPr id="1846298393" name="Slide Number Placeholder 5"/>
           <p:cNvSpPr>
             <a:spLocks noGrp="1"/>
           </p:cNvSpPr>
@@ -970,7 +1056,7 @@
       </p:grpSpPr>
       <p:sp>
         <p:nvSpPr>
-          <p:cNvPr id="1591761291" name="Title 1"/>
+          <p:cNvPr id="1396668855" name="Title 1"/>
           <p:cNvSpPr>
             <a:spLocks noGrp="1"/>
           </p:cNvSpPr>
@@ -996,7 +1082,7 @@
       </p:sp>
       <p:sp>
         <p:nvSpPr>
-          <p:cNvPr id="1895938412" name="Vertical Text Placeholder 2"/>
+          <p:cNvPr id="1816363399" name="Vertical Text Placeholder 2"/>
           <p:cNvSpPr>
             <a:spLocks noGrp="1"/>
           </p:cNvSpPr>
@@ -1062,7 +1148,7 @@
       </p:sp>
       <p:sp>
         <p:nvSpPr>
-          <p:cNvPr id="248374953" name="Date Placeholder 3"/>
+          <p:cNvPr id="1032246080" name="Date Placeholder 3"/>
           <p:cNvSpPr>
             <a:spLocks noGrp="1"/>
           </p:cNvSpPr>
@@ -1088,7 +1174,7 @@
       </p:sp>
       <p:sp>
         <p:nvSpPr>
-          <p:cNvPr id="449464276" name="Footer Placeholder 4"/>
+          <p:cNvPr id="1835152782" name="Footer Placeholder 4"/>
           <p:cNvSpPr>
             <a:spLocks noGrp="1"/>
           </p:cNvSpPr>
@@ -1110,7 +1196,7 @@
       </p:sp>
       <p:sp>
         <p:nvSpPr>
-          <p:cNvPr id="1326452473" name="Slide Number Placeholder 5"/>
+          <p:cNvPr id="1792529532" name="Slide Number Placeholder 5"/>
           <p:cNvSpPr>
             <a:spLocks noGrp="1"/>
           </p:cNvSpPr>
@@ -1161,7 +1247,7 @@
       </p:grpSpPr>
       <p:sp>
         <p:nvSpPr>
-          <p:cNvPr id="2095653671" name="Vertical Title 1"/>
+          <p:cNvPr id="62785338" name="Vertical Title 1"/>
           <p:cNvSpPr>
             <a:spLocks noGrp="1"/>
           </p:cNvSpPr>
@@ -1192,7 +1278,7 @@
       </p:sp>
       <p:sp>
         <p:nvSpPr>
-          <p:cNvPr id="1984809627" name="Vertical Text Placeholder 2"/>
+          <p:cNvPr id="2063317138" name="Vertical Text Placeholder 2"/>
           <p:cNvSpPr>
             <a:spLocks noGrp="1"/>
           </p:cNvSpPr>
@@ -1202,7 +1288,7 @@
         </p:nvSpPr>
         <p:spPr bwMode="auto">
           <a:xfrm>
-            <a:off x="838199" y="365125"/>
+            <a:off x="838198" y="365125"/>
             <a:ext cx="7734299" cy="5811838"/>
           </a:xfrm>
         </p:spPr>
@@ -1263,7 +1349,7 @@
       </p:sp>
       <p:sp>
         <p:nvSpPr>
-          <p:cNvPr id="203150509" name="Date Placeholder 3"/>
+          <p:cNvPr id="1104108262" name="Date Placeholder 3"/>
           <p:cNvSpPr>
             <a:spLocks noGrp="1"/>
           </p:cNvSpPr>
@@ -1289,7 +1375,7 @@
       </p:sp>
       <p:sp>
         <p:nvSpPr>
-          <p:cNvPr id="1837073053" name="Footer Placeholder 4"/>
+          <p:cNvPr id="1545069483" name="Footer Placeholder 4"/>
           <p:cNvSpPr>
             <a:spLocks noGrp="1"/>
           </p:cNvSpPr>
@@ -1311,7 +1397,7 @@
       </p:sp>
       <p:sp>
         <p:nvSpPr>
-          <p:cNvPr id="380575197" name="Slide Number Placeholder 5"/>
+          <p:cNvPr id="2100933612" name="Slide Number Placeholder 5"/>
           <p:cNvSpPr>
             <a:spLocks noGrp="1"/>
           </p:cNvSpPr>
@@ -1362,7 +1448,7 @@
       </p:grpSpPr>
       <p:sp>
         <p:nvSpPr>
-          <p:cNvPr id="949457623" name="Title 1"/>
+          <p:cNvPr id="1543531100" name="Title 1"/>
           <p:cNvSpPr>
             <a:spLocks noGrp="1"/>
           </p:cNvSpPr>
@@ -1388,7 +1474,7 @@
       </p:sp>
       <p:sp>
         <p:nvSpPr>
-          <p:cNvPr id="376874315" name="Content Placeholder 2"/>
+          <p:cNvPr id="1582790128" name="Content Placeholder 2"/>
           <p:cNvSpPr>
             <a:spLocks noGrp="1"/>
           </p:cNvSpPr>
@@ -1454,7 +1540,7 @@
       </p:sp>
       <p:sp>
         <p:nvSpPr>
-          <p:cNvPr id="410058279" name="Date Placeholder 3"/>
+          <p:cNvPr id="1393233214" name="Date Placeholder 3"/>
           <p:cNvSpPr>
             <a:spLocks noGrp="1"/>
           </p:cNvSpPr>
@@ -1480,7 +1566,7 @@
       </p:sp>
       <p:sp>
         <p:nvSpPr>
-          <p:cNvPr id="1062790488" name="Footer Placeholder 4"/>
+          <p:cNvPr id="800690537" name="Footer Placeholder 4"/>
           <p:cNvSpPr>
             <a:spLocks noGrp="1"/>
           </p:cNvSpPr>
@@ -1502,7 +1588,7 @@
       </p:sp>
       <p:sp>
         <p:nvSpPr>
-          <p:cNvPr id="103437872" name="Slide Number Placeholder 5"/>
+          <p:cNvPr id="365035716" name="Slide Number Placeholder 5"/>
           <p:cNvSpPr>
             <a:spLocks noGrp="1"/>
           </p:cNvSpPr>
@@ -1553,7 +1639,7 @@
       </p:grpSpPr>
       <p:sp>
         <p:nvSpPr>
-          <p:cNvPr id="837682932" name="Title 1"/>
+          <p:cNvPr id="5467756" name="Title 1"/>
           <p:cNvSpPr>
             <a:spLocks noGrp="1"/>
           </p:cNvSpPr>
@@ -1588,7 +1674,7 @@
       </p:sp>
       <p:sp>
         <p:nvSpPr>
-          <p:cNvPr id="1373908246" name="Text Placeholder 2"/>
+          <p:cNvPr id="1366894748" name="Text Placeholder 2"/>
           <p:cNvSpPr>
             <a:spLocks noGrp="1"/>
           </p:cNvSpPr>
@@ -1710,7 +1796,7 @@
       </p:sp>
       <p:sp>
         <p:nvSpPr>
-          <p:cNvPr id="1760997237" name="Date Placeholder 3"/>
+          <p:cNvPr id="325221928" name="Date Placeholder 3"/>
           <p:cNvSpPr>
             <a:spLocks noGrp="1"/>
           </p:cNvSpPr>
@@ -1736,7 +1822,7 @@
       </p:sp>
       <p:sp>
         <p:nvSpPr>
-          <p:cNvPr id="1806072136" name="Footer Placeholder 4"/>
+          <p:cNvPr id="1827717854" name="Footer Placeholder 4"/>
           <p:cNvSpPr>
             <a:spLocks noGrp="1"/>
           </p:cNvSpPr>
@@ -1758,7 +1844,7 @@
       </p:sp>
       <p:sp>
         <p:nvSpPr>
-          <p:cNvPr id="2023896595" name="Slide Number Placeholder 5"/>
+          <p:cNvPr id="1548929723" name="Slide Number Placeholder 5"/>
           <p:cNvSpPr>
             <a:spLocks noGrp="1"/>
           </p:cNvSpPr>
@@ -1809,7 +1895,7 @@
       </p:grpSpPr>
       <p:sp>
         <p:nvSpPr>
-          <p:cNvPr id="1458545277" name="Title 1"/>
+          <p:cNvPr id="972819643" name="Title 1"/>
           <p:cNvSpPr>
             <a:spLocks noGrp="1"/>
           </p:cNvSpPr>
@@ -1835,7 +1921,7 @@
       </p:sp>
       <p:sp>
         <p:nvSpPr>
-          <p:cNvPr id="1195476892" name="Content Placeholder 2"/>
+          <p:cNvPr id="1080501780" name="Content Placeholder 2"/>
           <p:cNvSpPr>
             <a:spLocks noGrp="1"/>
           </p:cNvSpPr>
@@ -1845,7 +1931,7 @@
         </p:nvSpPr>
         <p:spPr bwMode="auto">
           <a:xfrm>
-            <a:off x="838199" y="1825625"/>
+            <a:off x="838198" y="1825625"/>
             <a:ext cx="5181599" cy="4351338"/>
           </a:xfrm>
         </p:spPr>
@@ -1906,7 +1992,7 @@
       </p:sp>
       <p:sp>
         <p:nvSpPr>
-          <p:cNvPr id="1277599246" name="Content Placeholder 3"/>
+          <p:cNvPr id="924879927" name="Content Placeholder 3"/>
           <p:cNvSpPr>
             <a:spLocks noGrp="1"/>
           </p:cNvSpPr>
@@ -1977,7 +2063,7 @@
       </p:sp>
       <p:sp>
         <p:nvSpPr>
-          <p:cNvPr id="1741353163" name="Date Placeholder 4"/>
+          <p:cNvPr id="1377264753" name="Date Placeholder 4"/>
           <p:cNvSpPr>
             <a:spLocks noGrp="1"/>
           </p:cNvSpPr>
@@ -2003,7 +2089,7 @@
       </p:sp>
       <p:sp>
         <p:nvSpPr>
-          <p:cNvPr id="575397542" name="Footer Placeholder 5"/>
+          <p:cNvPr id="1996608190" name="Footer Placeholder 5"/>
           <p:cNvSpPr>
             <a:spLocks noGrp="1"/>
           </p:cNvSpPr>
@@ -2025,7 +2111,7 @@
       </p:sp>
       <p:sp>
         <p:nvSpPr>
-          <p:cNvPr id="376289827" name="Slide Number Placeholder 6"/>
+          <p:cNvPr id="193479472" name="Slide Number Placeholder 6"/>
           <p:cNvSpPr>
             <a:spLocks noGrp="1"/>
           </p:cNvSpPr>
@@ -2076,7 +2162,7 @@
       </p:grpSpPr>
       <p:sp>
         <p:nvSpPr>
-          <p:cNvPr id="1729824288" name="Title 1"/>
+          <p:cNvPr id="1397643432" name="Title 1"/>
           <p:cNvSpPr>
             <a:spLocks noGrp="1"/>
           </p:cNvSpPr>
@@ -2107,7 +2193,7 @@
       </p:sp>
       <p:sp>
         <p:nvSpPr>
-          <p:cNvPr id="808627130" name="Text Placeholder 2"/>
+          <p:cNvPr id="802837507" name="Text Placeholder 2"/>
           <p:cNvSpPr>
             <a:spLocks noGrp="1"/>
           </p:cNvSpPr>
@@ -2118,7 +2204,7 @@
         <p:spPr bwMode="auto">
           <a:xfrm>
             <a:off x="839789" y="1681162"/>
-            <a:ext cx="5157786" cy="823911"/>
+            <a:ext cx="5157785" cy="823911"/>
           </a:xfrm>
         </p:spPr>
         <p:txBody>
@@ -2175,7 +2261,7 @@
       </p:sp>
       <p:sp>
         <p:nvSpPr>
-          <p:cNvPr id="642145161" name="Content Placeholder 3"/>
+          <p:cNvPr id="1827052119" name="Content Placeholder 3"/>
           <p:cNvSpPr>
             <a:spLocks noGrp="1"/>
           </p:cNvSpPr>
@@ -2186,7 +2272,7 @@
         <p:spPr bwMode="auto">
           <a:xfrm>
             <a:off x="839789" y="2505074"/>
-            <a:ext cx="5157786" cy="3684587"/>
+            <a:ext cx="5157785" cy="3684587"/>
           </a:xfrm>
         </p:spPr>
         <p:txBody>
@@ -2246,7 +2332,7 @@
       </p:sp>
       <p:sp>
         <p:nvSpPr>
-          <p:cNvPr id="329412359" name="Text Placeholder 4"/>
+          <p:cNvPr id="138598488" name="Text Placeholder 4"/>
           <p:cNvSpPr>
             <a:spLocks noGrp="1"/>
           </p:cNvSpPr>
@@ -2314,7 +2400,7 @@
       </p:sp>
       <p:sp>
         <p:nvSpPr>
-          <p:cNvPr id="699216521" name="Content Placeholder 5"/>
+          <p:cNvPr id="951140037" name="Content Placeholder 5"/>
           <p:cNvSpPr>
             <a:spLocks noGrp="1"/>
           </p:cNvSpPr>
@@ -2385,7 +2471,7 @@
       </p:sp>
       <p:sp>
         <p:nvSpPr>
-          <p:cNvPr id="805044996" name="Date Placeholder 6"/>
+          <p:cNvPr id="1193453827" name="Date Placeholder 6"/>
           <p:cNvSpPr>
             <a:spLocks noGrp="1"/>
           </p:cNvSpPr>
@@ -2411,7 +2497,7 @@
       </p:sp>
       <p:sp>
         <p:nvSpPr>
-          <p:cNvPr id="454604785" name="Footer Placeholder 7"/>
+          <p:cNvPr id="544646568" name="Footer Placeholder 7"/>
           <p:cNvSpPr>
             <a:spLocks noGrp="1"/>
           </p:cNvSpPr>
@@ -2433,7 +2519,7 @@
       </p:sp>
       <p:sp>
         <p:nvSpPr>
-          <p:cNvPr id="715127230" name="Slide Number Placeholder 8"/>
+          <p:cNvPr id="1029101896" name="Slide Number Placeholder 8"/>
           <p:cNvSpPr>
             <a:spLocks noGrp="1"/>
           </p:cNvSpPr>
@@ -2484,7 +2570,7 @@
       </p:grpSpPr>
       <p:sp>
         <p:nvSpPr>
-          <p:cNvPr id="463924848" name="Title 1"/>
+          <p:cNvPr id="628701129" name="Title 1"/>
           <p:cNvSpPr>
             <a:spLocks noGrp="1"/>
           </p:cNvSpPr>
@@ -2510,7 +2596,7 @@
       </p:sp>
       <p:sp>
         <p:nvSpPr>
-          <p:cNvPr id="1195226433" name="Date Placeholder 2"/>
+          <p:cNvPr id="2005493951" name="Date Placeholder 2"/>
           <p:cNvSpPr>
             <a:spLocks noGrp="1"/>
           </p:cNvSpPr>
@@ -2536,7 +2622,7 @@
       </p:sp>
       <p:sp>
         <p:nvSpPr>
-          <p:cNvPr id="1656755875" name="Footer Placeholder 3"/>
+          <p:cNvPr id="399058548" name="Footer Placeholder 3"/>
           <p:cNvSpPr>
             <a:spLocks noGrp="1"/>
           </p:cNvSpPr>
@@ -2558,7 +2644,7 @@
       </p:sp>
       <p:sp>
         <p:nvSpPr>
-          <p:cNvPr id="673718522" name="Slide Number Placeholder 4"/>
+          <p:cNvPr id="1859452376" name="Slide Number Placeholder 4"/>
           <p:cNvSpPr>
             <a:spLocks noGrp="1"/>
           </p:cNvSpPr>
@@ -2609,7 +2695,7 @@
       </p:grpSpPr>
       <p:sp>
         <p:nvSpPr>
-          <p:cNvPr id="790625864" name="Date Placeholder 1"/>
+          <p:cNvPr id="1184049806" name="Date Placeholder 1"/>
           <p:cNvSpPr>
             <a:spLocks noGrp="1"/>
           </p:cNvSpPr>
@@ -2635,7 +2721,7 @@
       </p:sp>
       <p:sp>
         <p:nvSpPr>
-          <p:cNvPr id="1005882407" name="Footer Placeholder 2"/>
+          <p:cNvPr id="740157845" name="Footer Placeholder 2"/>
           <p:cNvSpPr>
             <a:spLocks noGrp="1"/>
           </p:cNvSpPr>
@@ -2657,7 +2743,7 @@
       </p:sp>
       <p:sp>
         <p:nvSpPr>
-          <p:cNvPr id="660735573" name="Slide Number Placeholder 3"/>
+          <p:cNvPr id="1481481628" name="Slide Number Placeholder 3"/>
           <p:cNvSpPr>
             <a:spLocks noGrp="1"/>
           </p:cNvSpPr>
@@ -2708,7 +2794,7 @@
       </p:grpSpPr>
       <p:sp>
         <p:nvSpPr>
-          <p:cNvPr id="895454327" name="Title 1"/>
+          <p:cNvPr id="1093360032" name="Title 1"/>
           <p:cNvSpPr>
             <a:spLocks noGrp="1"/>
           </p:cNvSpPr>
@@ -2743,7 +2829,7 @@
       </p:sp>
       <p:sp>
         <p:nvSpPr>
-          <p:cNvPr id="678051156" name="Content Placeholder 2"/>
+          <p:cNvPr id="1181889360" name="Content Placeholder 2"/>
           <p:cNvSpPr>
             <a:spLocks noGrp="1"/>
           </p:cNvSpPr>
@@ -2842,7 +2928,7 @@
       </p:sp>
       <p:sp>
         <p:nvSpPr>
-          <p:cNvPr id="304106131" name="Text Placeholder 3"/>
+          <p:cNvPr id="975395812" name="Text Placeholder 3"/>
           <p:cNvSpPr>
             <a:spLocks noGrp="1"/>
           </p:cNvSpPr>
@@ -2910,7 +2996,7 @@
       </p:sp>
       <p:sp>
         <p:nvSpPr>
-          <p:cNvPr id="244991317" name="Date Placeholder 4"/>
+          <p:cNvPr id="480821974" name="Date Placeholder 4"/>
           <p:cNvSpPr>
             <a:spLocks noGrp="1"/>
           </p:cNvSpPr>
@@ -2936,7 +3022,7 @@
       </p:sp>
       <p:sp>
         <p:nvSpPr>
-          <p:cNvPr id="1067475066" name="Footer Placeholder 5"/>
+          <p:cNvPr id="488131742" name="Footer Placeholder 5"/>
           <p:cNvSpPr>
             <a:spLocks noGrp="1"/>
           </p:cNvSpPr>
@@ -2958,7 +3044,7 @@
       </p:sp>
       <p:sp>
         <p:nvSpPr>
-          <p:cNvPr id="105309724" name="Slide Number Placeholder 6"/>
+          <p:cNvPr id="1306805901" name="Slide Number Placeholder 6"/>
           <p:cNvSpPr>
             <a:spLocks noGrp="1"/>
           </p:cNvSpPr>
@@ -3009,7 +3095,7 @@
       </p:grpSpPr>
       <p:sp>
         <p:nvSpPr>
-          <p:cNvPr id="57524858" name="Title 1"/>
+          <p:cNvPr id="119689516" name="Title 1"/>
           <p:cNvSpPr>
             <a:spLocks noGrp="1"/>
           </p:cNvSpPr>
@@ -3044,7 +3130,7 @@
       </p:sp>
       <p:sp>
         <p:nvSpPr>
-          <p:cNvPr id="623507683" name="Picture Placeholder 2"/>
+          <p:cNvPr id="2123459081" name="Picture Placeholder 2"/>
           <p:cNvSpPr>
             <a:spLocks noChangeAspect="1" noGrp="1"/>
           </p:cNvSpPr>
@@ -3112,7 +3198,7 @@
       </p:sp>
       <p:sp>
         <p:nvSpPr>
-          <p:cNvPr id="1469033554" name="Text Placeholder 3"/>
+          <p:cNvPr id="1020345983" name="Text Placeholder 3"/>
           <p:cNvSpPr>
             <a:spLocks noGrp="1"/>
           </p:cNvSpPr>
@@ -3180,7 +3266,7 @@
       </p:sp>
       <p:sp>
         <p:nvSpPr>
-          <p:cNvPr id="221810192" name="Date Placeholder 4"/>
+          <p:cNvPr id="2038311731" name="Date Placeholder 4"/>
           <p:cNvSpPr>
             <a:spLocks noGrp="1"/>
           </p:cNvSpPr>
@@ -3206,7 +3292,7 @@
       </p:sp>
       <p:sp>
         <p:nvSpPr>
-          <p:cNvPr id="1872650951" name="Footer Placeholder 5"/>
+          <p:cNvPr id="2046616690" name="Footer Placeholder 5"/>
           <p:cNvSpPr>
             <a:spLocks noGrp="1"/>
           </p:cNvSpPr>
@@ -3228,7 +3314,7 @@
       </p:sp>
       <p:sp>
         <p:nvSpPr>
-          <p:cNvPr id="188954123" name="Slide Number Placeholder 6"/>
+          <p:cNvPr id="939073782" name="Slide Number Placeholder 6"/>
           <p:cNvSpPr>
             <a:spLocks noGrp="1"/>
           </p:cNvSpPr>
@@ -3284,7 +3370,7 @@
       </p:grpSpPr>
       <p:sp>
         <p:nvSpPr>
-          <p:cNvPr id="16283324" name="Title Placeholder 1"/>
+          <p:cNvPr id="720360839" name="Title Placeholder 1"/>
           <p:cNvSpPr>
             <a:spLocks noGrp="1"/>
           </p:cNvSpPr>
@@ -3294,7 +3380,7 @@
         </p:nvSpPr>
         <p:spPr bwMode="auto">
           <a:xfrm>
-            <a:off x="838199" y="365125"/>
+            <a:off x="838198" y="365125"/>
             <a:ext cx="10515600" cy="1325562"/>
           </a:xfrm>
           <a:prstGeom prst="rect">
@@ -3320,7 +3406,7 @@
       </p:sp>
       <p:sp>
         <p:nvSpPr>
-          <p:cNvPr id="2062561272" name="Text Placeholder 2"/>
+          <p:cNvPr id="1018791544" name="Text Placeholder 2"/>
           <p:cNvSpPr>
             <a:spLocks noGrp="1"/>
           </p:cNvSpPr>
@@ -3330,7 +3416,7 @@
         </p:nvSpPr>
         <p:spPr bwMode="auto">
           <a:xfrm>
-            <a:off x="838199" y="1825625"/>
+            <a:off x="838198" y="1825625"/>
             <a:ext cx="10515600" cy="4351338"/>
           </a:xfrm>
           <a:prstGeom prst="rect">
@@ -3396,7 +3482,7 @@
       </p:sp>
       <p:sp>
         <p:nvSpPr>
-          <p:cNvPr id="2102667395" name="Date Placeholder 3"/>
+          <p:cNvPr id="985509832" name="Date Placeholder 3"/>
           <p:cNvSpPr>
             <a:spLocks noGrp="1"/>
           </p:cNvSpPr>
@@ -3406,7 +3492,7 @@
         </p:nvSpPr>
         <p:spPr bwMode="auto">
           <a:xfrm>
-            <a:off x="838199" y="6356350"/>
+            <a:off x="838198" y="6356350"/>
             <a:ext cx="2743200" cy="365125"/>
           </a:xfrm>
           <a:prstGeom prst="rect">
@@ -3440,7 +3526,7 @@
       </p:sp>
       <p:sp>
         <p:nvSpPr>
-          <p:cNvPr id="1895713968" name="Footer Placeholder 4"/>
+          <p:cNvPr id="584414225" name="Footer Placeholder 4"/>
           <p:cNvSpPr>
             <a:spLocks noGrp="1"/>
           </p:cNvSpPr>
@@ -3450,7 +3536,7 @@
         </p:nvSpPr>
         <p:spPr bwMode="auto">
           <a:xfrm>
-            <a:off x="4038599" y="6356350"/>
+            <a:off x="4038598" y="6356350"/>
             <a:ext cx="4114800" cy="365125"/>
           </a:xfrm>
           <a:prstGeom prst="rect">
@@ -3480,7 +3566,7 @@
       </p:sp>
       <p:sp>
         <p:nvSpPr>
-          <p:cNvPr id="1108714839" name="Slide Number Placeholder 5"/>
+          <p:cNvPr id="75101957" name="Slide Number Placeholder 5"/>
           <p:cNvSpPr>
             <a:spLocks noGrp="1"/>
           </p:cNvSpPr>
@@ -3841,7 +3927,7 @@
       </p:grpSpPr>
       <p:sp>
         <p:nvSpPr>
-          <p:cNvPr id="1783297883" name="Title 1"/>
+          <p:cNvPr id="1795494015" name="Title 1"/>
           <p:cNvSpPr>
             <a:spLocks noGrp="1"/>
           </p:cNvSpPr>
@@ -3883,7 +3969,7 @@
       </p:sp>
       <p:sp>
         <p:nvSpPr>
-          <p:cNvPr id="771422501" name="Content Placeholder 2"/>
+          <p:cNvPr id="1204641990" name="Content Placeholder 2"/>
           <p:cNvSpPr>
             <a:spLocks noGrp="1"/>
           </p:cNvSpPr>
@@ -3893,50 +3979,30 @@
         </p:nvSpPr>
         <p:spPr bwMode="auto"/>
         <p:txBody>
-          <a:bodyPr/>
-          <a:lstStyle/>
-          <a:p>
-            <a:pPr marL="0" indent="0">
-              <a:buFont typeface="Arial"/>
-              <a:buNone/>
-              <a:defRPr/>
-            </a:pPr>
-            <a:r>
-              <a:rPr/>
+          <a:bodyPr vertOverflow="overflow" horzOverflow="overflow" vert="horz" wrap="square" lIns="91440" tIns="45720" rIns="91440" bIns="45720" numCol="1" spcCol="0" rtlCol="0" fromWordArt="0" anchor="t" anchorCtr="0" forceAA="0" upright="0" compatLnSpc="0">
+            <a:normAutofit/>
+          </a:bodyPr>
+          <a:lstStyle/>
+          <a:p>
+            <a:pPr>
+              <a:defRPr/>
+            </a:pPr>
+            <a:r>
+              <a:rPr sz="2800" b="0"/>
               <a:t>Created by: Chris Wahrenburg</a:t>
             </a:r>
-            <a:endParaRPr/>
-          </a:p>
-          <a:p>
-            <a:pPr marL="0" indent="0">
-              <a:buFont typeface="Arial"/>
-              <a:buNone/>
-              <a:defRPr/>
-            </a:pPr>
-            <a:endParaRPr/>
-          </a:p>
-          <a:p>
-            <a:pPr marL="0" indent="0">
-              <a:buFont typeface="Arial"/>
-              <a:buNone/>
-              <a:defRPr/>
-            </a:pPr>
-            <a:r>
-              <a:rPr/>
-              <a:t>Contact</a:t>
-            </a:r>
-            <a:endParaRPr/>
-          </a:p>
-          <a:p>
-            <a:pPr>
-              <a:defRPr/>
-            </a:pPr>
-            <a:r>
-              <a:rPr b="1"/>
+            <a:endParaRPr sz="3600" b="0"/>
+          </a:p>
+          <a:p>
+            <a:pPr>
+              <a:defRPr/>
+            </a:pPr>
+            <a:r>
+              <a:rPr sz="2800" b="0"/>
               <a:t>Github: </a:t>
             </a:r>
             <a:r>
-              <a:rPr lang="en-US" sz="2100" b="0" i="0" u="sng" strike="noStrike" cap="none" spc="0">
+              <a:rPr lang="en-US" sz="2800" b="0" i="0" u="sng" strike="noStrike" cap="none" spc="0">
                 <a:solidFill>
                   <a:schemeClr val="tx1"/>
                 </a:solidFill>
@@ -3945,49 +4011,39 @@
                 <a:cs typeface="Arial"/>
                 <a:hlinkClick r:id="rId3" tooltip=""/>
               </a:rPr>
-              <a:t>https://github.com/cwahrenburg</a:t>
-            </a:r>
-            <a:endParaRPr/>
-          </a:p>
-          <a:p>
-            <a:pPr>
-              <a:defRPr/>
-            </a:pPr>
-            <a:r>
-              <a:rPr/>
+              <a:t>https://github.com/cwahrenburg/spc</a:t>
+            </a:r>
+            <a:endParaRPr sz="2800" b="0"/>
+          </a:p>
+          <a:p>
+            <a:pPr>
+              <a:defRPr/>
+            </a:pPr>
+            <a:r>
+              <a:rPr sz="2800" b="0"/>
               <a:t>edX: cpw712</a:t>
             </a:r>
-            <a:endParaRPr/>
-          </a:p>
-          <a:p>
-            <a:pPr>
-              <a:defRPr/>
-            </a:pPr>
-            <a:r>
-              <a:rPr/>
-              <a:t>Madison, USA</a:t>
-            </a:r>
-            <a:endParaRPr/>
-          </a:p>
-          <a:p>
-            <a:pPr>
-              <a:defRPr/>
-            </a:pPr>
-            <a:r>
-              <a:rPr/>
-              <a:t>Date: </a:t>
-            </a:r>
-            <a:r>
-              <a:rPr b="1"/>
-              <a:t>FILL Out when complete</a:t>
-            </a:r>
-            <a:endParaRPr b="1"/>
-          </a:p>
-          <a:p>
-            <a:pPr>
-              <a:defRPr/>
-            </a:pPr>
-            <a:endParaRPr/>
+            <a:endParaRPr sz="2800" b="0"/>
+          </a:p>
+          <a:p>
+            <a:pPr>
+              <a:defRPr/>
+            </a:pPr>
+            <a:r>
+              <a:rPr sz="2800" b="0"/>
+              <a:t>Madison, CT USA</a:t>
+            </a:r>
+            <a:endParaRPr sz="2800" b="0"/>
+          </a:p>
+          <a:p>
+            <a:pPr>
+              <a:defRPr/>
+            </a:pPr>
+            <a:r>
+              <a:rPr sz="2800" b="0"/>
+              <a:t>March 27, 2026</a:t>
+            </a:r>
+            <a:endParaRPr sz="2800" b="0"/>
           </a:p>
         </p:txBody>
       </p:sp>
@@ -4026,7 +4082,7 @@
       </p:grpSpPr>
       <p:sp>
         <p:nvSpPr>
-          <p:cNvPr id="1384840218" name="Title 1"/>
+          <p:cNvPr id="183054780" name="Title 1"/>
           <p:cNvSpPr>
             <a:spLocks noGrp="1"/>
           </p:cNvSpPr>
@@ -4052,7 +4108,7 @@
       </p:sp>
       <p:sp>
         <p:nvSpPr>
-          <p:cNvPr id="457627938" name="Content Placeholder 2"/>
+          <p:cNvPr id="1643499107" name="Content Placeholder 2"/>
           <p:cNvSpPr>
             <a:spLocks noGrp="1"/>
           </p:cNvSpPr>
@@ -4102,13 +4158,8 @@
               <a:t>(</a:t>
             </a:r>
             <a:r>
-              <a:rPr lang="en-US" sz="2000" b="0" i="0" u="none" strike="noStrike" cap="none" spc="0">
-                <a:solidFill>
-                  <a:schemeClr val="tx1"/>
-                </a:solidFill>
-                <a:latin typeface="Arial"/>
-                <a:ea typeface="Arial"/>
-                <a:cs typeface="Arial"/>
+              <a:rPr sz="2000" u="sng">
+                <a:hlinkClick r:id="rId3" tooltip=""/>
               </a:rPr>
               <a:t>https://asq.org/quality-resources/statistical-process-control</a:t>
             </a:r>
@@ -4160,7 +4211,7 @@
                 <a:latin typeface="Arial"/>
                 <a:ea typeface="Arial"/>
                 <a:cs typeface="Arial"/>
-                <a:hlinkClick r:id="rId3" tooltip=""/>
+                <a:hlinkClick r:id="rId4" tooltip=""/>
               </a:rPr>
               <a:t>https://en.wikipedia.org/wiki/Nelson_rules</a:t>
             </a:r>
@@ -4263,7 +4314,133 @@
       </p:grpSpPr>
       <p:sp>
         <p:nvSpPr>
-          <p:cNvPr id="1129315133" name="Title 1"/>
+          <p:cNvPr id="1599076369" name="Title 1"/>
+          <p:cNvSpPr>
+            <a:spLocks noGrp="1"/>
+          </p:cNvSpPr>
+          <p:nvPr>
+            <p:ph type="title"/>
+          </p:nvPr>
+        </p:nvSpPr>
+        <p:spPr bwMode="auto">
+          <a:xfrm flipH="0" flipV="0">
+            <a:off x="838198" y="365124"/>
+            <a:ext cx="3184466" cy="5837740"/>
+          </a:xfrm>
+        </p:spPr>
+        <p:txBody>
+          <a:bodyPr vertOverflow="overflow" horzOverflow="overflow" vert="horz" wrap="square" lIns="91440" tIns="45720" rIns="91440" bIns="45720" numCol="1" spcCol="0" rtlCol="0" fromWordArt="0" anchor="ctr" anchorCtr="0" forceAA="0" upright="0" compatLnSpc="0">
+            <a:normAutofit/>
+          </a:bodyPr>
+          <a:lstStyle/>
+          <a:p>
+            <a:pPr>
+              <a:defRPr/>
+            </a:pPr>
+            <a:r>
+              <a:rPr b="1"/>
+              <a:t>SPC Rules</a:t>
+            </a:r>
+            <a:r>
+              <a:rPr/>
+              <a:t>: </a:t>
+            </a:r>
+            <a:br>
+              <a:rPr/>
+            </a:br>
+            <a:br>
+              <a:rPr/>
+            </a:br>
+            <a:r>
+              <a:rPr/>
+              <a:t>Differentiate signal from noise.</a:t>
+            </a:r>
+            <a:br>
+              <a:rPr/>
+            </a:br>
+            <a:br>
+              <a:rPr sz="2000"/>
+            </a:br>
+            <a:br>
+              <a:rPr sz="2000"/>
+            </a:br>
+            <a:r>
+              <a:rPr lang="en-US" sz="1800" b="0" i="0" u="sng" strike="noStrike" cap="none" spc="0">
+                <a:solidFill>
+                  <a:schemeClr val="tx1"/>
+                </a:solidFill>
+                <a:latin typeface="Arial"/>
+                <a:ea typeface="Arial"/>
+                <a:cs typeface="Arial"/>
+                <a:hlinkClick r:id="rId3" tooltip=""/>
+              </a:rPr>
+              <a:t>https://en.wikipedia.org/wiki/Nelson_rules</a:t>
+            </a:r>
+            <a:br>
+              <a:rPr sz="2000"/>
+            </a:br>
+            <a:endParaRPr/>
+          </a:p>
+        </p:txBody>
+      </p:sp>
+      <p:pic>
+        <p:nvPicPr>
+          <p:cNvPr id="647722258" name=""/>
+          <p:cNvPicPr>
+            <a:picLocks noChangeAspect="1"/>
+          </p:cNvPicPr>
+          <p:nvPr/>
+        </p:nvPicPr>
+        <p:blipFill rotWithShape="1">
+          <a:blip r:embed="rId4"/>
+          <a:stretch/>
+        </p:blipFill>
+        <p:spPr bwMode="auto">
+          <a:xfrm flipH="0" flipV="0">
+            <a:off x="4022665" y="208852"/>
+            <a:ext cx="7929118" cy="6440293"/>
+          </a:xfrm>
+          <a:prstGeom prst="rect">
+            <a:avLst/>
+          </a:prstGeom>
+        </p:spPr>
+      </p:pic>
+    </p:spTree>
+  </p:cSld>
+  <p:clrMapOvr>
+    <a:masterClrMapping/>
+  </p:clrMapOvr>
+  <mc:AlternateContent xmlns:mc="http://schemas.openxmlformats.org/markup-compatibility/2006">
+    <mc:Choice xmlns:p159="http://schemas.microsoft.com/office/powerpoint/2015/09/main" xmlns:p14="http://schemas.microsoft.com/office/powerpoint/2010/main" Requires="p159">
+      <p:transition p14:dur="2000" advClick="1"/>
+    </mc:Choice>
+    <mc:Fallback>
+      <p:transition advClick="1"/>
+    </mc:Fallback>
+  </mc:AlternateContent>
+</p:sld>
+</file>
+
+<file path=ppt/slides/slide4.xml><?xml version="1.0" encoding="utf-8"?>
+<p:sld xmlns:a="http://schemas.openxmlformats.org/drawingml/2006/main" xmlns:r="http://schemas.openxmlformats.org/officeDocument/2006/relationships" xmlns:p="http://schemas.openxmlformats.org/presentationml/2006/main" xmlns:m="http://schemas.openxmlformats.org/officeDocument/2006/math" xmlns:w="http://schemas.openxmlformats.org/wordprocessingml/2006/main" xmlns:mc="http://schemas.openxmlformats.org/markup-compatibility/2006" showMasterPhAnim="0" showMasterSp="1" show="1">
+  <p:cSld name="">
+    <p:spTree>
+      <p:nvGrpSpPr>
+        <p:cNvPr id="1" name=""/>
+        <p:cNvGrpSpPr/>
+        <p:nvPr/>
+      </p:nvGrpSpPr>
+      <p:grpSpPr bwMode="auto">
+        <a:xfrm>
+          <a:off x="0" y="0"/>
+          <a:ext cx="0" cy="0"/>
+          <a:chOff x="0" y="0"/>
+          <a:chExt cx="0" cy="0"/>
+        </a:xfrm>
+      </p:grpSpPr>
+      <p:sp>
+        <p:nvSpPr>
+          <p:cNvPr id="1700833716" name="Title 1"/>
           <p:cNvSpPr>
             <a:spLocks noGrp="1"/>
           </p:cNvSpPr>
@@ -4289,13 +4466,13 @@
       </p:sp>
       <p:graphicFrame>
         <p:nvGraphicFramePr>
-          <p:cNvPr id="2123760398" name=""/>
+          <p:cNvPr id="781671896" name=""/>
           <p:cNvGraphicFramePr>
             <a:graphicFrameLocks xmlns:a="http://schemas.openxmlformats.org/drawingml/2006/main"/>
           </p:cNvGraphicFramePr>
           <p:nvPr/>
         </p:nvGraphicFramePr>
-        <p:xfrm>
+        <p:xfrm rot="0">
           <a:off x="664103" y="2123016"/>
           <a:ext cx="4157133" cy="3362450"/>
         </p:xfrm>
@@ -4485,7 +4662,7 @@
       </p:graphicFrame>
       <p:pic>
         <p:nvPicPr>
-          <p:cNvPr id="127404461" name=""/>
+          <p:cNvPr id="81338128" name=""/>
           <p:cNvPicPr>
             <a:picLocks noChangeAspect="1"/>
           </p:cNvPicPr>

</xml_diff>